<commit_message>
Small Changes to presentation
</commit_message>
<xml_diff>
--- a/Präsi/PP.pptx
+++ b/Präsi/PP.pptx
@@ -17363,9 +17363,21 @@
                 <a:cs typeface="Poppins"/>
                 <a:sym typeface="Poppins"/>
               </a:rPr>
-              <a:t>DAS SKALIERUNGS-PARADOXON</a:t>
-            </a:r>
-            <a:endParaRPr sz="1350" dirty="0">
+              <a:t>Das </a:t>
+            </a:r>
+            <a:r>
+              <a:rPr lang="en-US" sz="2475" b="1" dirty="0" err="1">
+                <a:solidFill>
+                  <a:schemeClr val="bg1"/>
+                </a:solidFill>
+                <a:latin typeface="Cambria" panose="02040503050406030204" pitchFamily="18" charset="0"/>
+                <a:ea typeface="Cambria" panose="02040503050406030204" pitchFamily="18" charset="0"/>
+                <a:cs typeface="Poppins"/>
+                <a:sym typeface="Poppins"/>
+              </a:rPr>
+              <a:t>Skalierungs-Paradoxon</a:t>
+            </a:r>
+            <a:endParaRPr lang="en-US" sz="1350" dirty="0">
               <a:solidFill>
                 <a:schemeClr val="bg1"/>
               </a:solidFill>
@@ -17783,18 +17795,98 @@
           </a:ln>
         </p:spPr>
       </p:pic>
+      <p:sp>
+        <p:nvSpPr>
+          <p:cNvPr id="3" name="Shape 1">
+            <a:extLst>
+              <a:ext uri="{FF2B5EF4-FFF2-40B4-BE49-F238E27FC236}">
+                <a16:creationId xmlns:a16="http://schemas.microsoft.com/office/drawing/2014/main" id="{6BFA9CF9-0227-1D01-D965-9C13FDC69F2A}"/>
+              </a:ext>
+            </a:extLst>
+          </p:cNvPr>
+          <p:cNvSpPr/>
+          <p:nvPr/>
+        </p:nvSpPr>
+        <p:spPr>
+          <a:xfrm>
+            <a:off x="0" y="0"/>
+            <a:ext cx="9144000" cy="45720"/>
+          </a:xfrm>
+          <a:prstGeom prst="rect">
+            <a:avLst/>
+          </a:prstGeom>
+          <a:solidFill>
+            <a:srgbClr val="0D9488"/>
+          </a:solidFill>
+          <a:ln w="12700">
+            <a:solidFill>
+              <a:srgbClr val="0D9488"/>
+            </a:solidFill>
+            <a:prstDash val="solid"/>
+          </a:ln>
+        </p:spPr>
+        <p:txBody>
+          <a:bodyPr/>
+          <a:lstStyle/>
+          <a:p>
+            <a:endParaRPr lang="de-DE"/>
+          </a:p>
+        </p:txBody>
+      </p:sp>
+      <p:sp>
+        <p:nvSpPr>
+          <p:cNvPr id="4" name="Text 2">
+            <a:extLst>
+              <a:ext uri="{FF2B5EF4-FFF2-40B4-BE49-F238E27FC236}">
+                <a16:creationId xmlns:a16="http://schemas.microsoft.com/office/drawing/2014/main" id="{122D5AE4-2A46-75B2-6B73-CC8804D08D12}"/>
+              </a:ext>
+            </a:extLst>
+          </p:cNvPr>
+          <p:cNvSpPr/>
+          <p:nvPr/>
+        </p:nvSpPr>
+        <p:spPr>
+          <a:xfrm>
+            <a:off x="457200" y="54864"/>
+            <a:ext cx="3200400" cy="256032"/>
+          </a:xfrm>
+          <a:prstGeom prst="rect">
+            <a:avLst/>
+          </a:prstGeom>
+          <a:noFill/>
+          <a:ln/>
+        </p:spPr>
+        <p:txBody>
+          <a:bodyPr wrap="square" lIns="0" tIns="0" rIns="0" bIns="0" rtlCol="0" anchor="ctr"/>
+          <a:lstStyle/>
+          <a:p>
+            <a:pPr marL="0" indent="0">
+              <a:buNone/>
+            </a:pPr>
+            <a:r>
+              <a:rPr lang="en-US" sz="900" b="1" kern="0" spc="300" dirty="0">
+                <a:solidFill>
+                  <a:srgbClr val="14B8A6"/>
+                </a:solidFill>
+              </a:rPr>
+              <a:t>FEATURE VALIDATION</a:t>
+            </a:r>
+            <a:endParaRPr lang="en-US" sz="900" dirty="0"/>
+          </a:p>
+        </p:txBody>
+      </p:sp>
     </p:spTree>
   </p:cSld>
   <p:clrMapOvr>
     <a:masterClrMapping/>
   </p:clrMapOvr>
-  <mc:AlternateContent xmlns:mc="http://schemas.openxmlformats.org/markup-compatibility/2006">
-    <mc:Choice xmlns:p159="http://schemas.microsoft.com/office/powerpoint/2015/09/main" Requires="p159">
+  <mc:AlternateContent xmlns:mc="http://schemas.openxmlformats.org/markup-compatibility/2006" xmlns:p159="http://schemas.microsoft.com/office/powerpoint/2015/09/main">
+    <mc:Choice Requires="p159">
       <p:transition xmlns:p14="http://schemas.microsoft.com/office/powerpoint/2010/main" spd="slow" p14:dur="2000">
         <p159:morph option="byObject"/>
       </p:transition>
     </mc:Choice>
-    <mc:Fallback>
+    <mc:Fallback xmlns="">
       <p:transition spd="slow">
         <p:fade/>
       </p:transition>
@@ -18995,7 +19087,19 @@
                 <a:cs typeface="Poppins"/>
                 <a:sym typeface="Poppins"/>
               </a:rPr>
-              <a:t>DAS SKALIERUNGS-PARADOXON</a:t>
+              <a:t>Das </a:t>
+            </a:r>
+            <a:r>
+              <a:rPr lang="en-US" sz="2475" b="1" dirty="0" err="1">
+                <a:solidFill>
+                  <a:schemeClr val="bg1"/>
+                </a:solidFill>
+                <a:latin typeface="Cambria" panose="02040503050406030204" pitchFamily="18" charset="0"/>
+                <a:ea typeface="Cambria" panose="02040503050406030204" pitchFamily="18" charset="0"/>
+                <a:cs typeface="Poppins"/>
+                <a:sym typeface="Poppins"/>
+              </a:rPr>
+              <a:t>Skalierungs-Paradoxon</a:t>
             </a:r>
             <a:endParaRPr sz="1350" dirty="0">
               <a:solidFill>
@@ -19415,6 +19519,86 @@
           </a:ln>
         </p:spPr>
       </p:pic>
+      <p:sp>
+        <p:nvSpPr>
+          <p:cNvPr id="6" name="Shape 1">
+            <a:extLst>
+              <a:ext uri="{FF2B5EF4-FFF2-40B4-BE49-F238E27FC236}">
+                <a16:creationId xmlns:a16="http://schemas.microsoft.com/office/drawing/2014/main" id="{01523E4A-FC0C-74D3-021C-79A1C85076B5}"/>
+              </a:ext>
+            </a:extLst>
+          </p:cNvPr>
+          <p:cNvSpPr/>
+          <p:nvPr/>
+        </p:nvSpPr>
+        <p:spPr>
+          <a:xfrm>
+            <a:off x="0" y="0"/>
+            <a:ext cx="9144000" cy="45720"/>
+          </a:xfrm>
+          <a:prstGeom prst="rect">
+            <a:avLst/>
+          </a:prstGeom>
+          <a:solidFill>
+            <a:srgbClr val="0D9488"/>
+          </a:solidFill>
+          <a:ln w="12700">
+            <a:solidFill>
+              <a:srgbClr val="0D9488"/>
+            </a:solidFill>
+            <a:prstDash val="solid"/>
+          </a:ln>
+        </p:spPr>
+        <p:txBody>
+          <a:bodyPr/>
+          <a:lstStyle/>
+          <a:p>
+            <a:endParaRPr lang="de-DE"/>
+          </a:p>
+        </p:txBody>
+      </p:sp>
+      <p:sp>
+        <p:nvSpPr>
+          <p:cNvPr id="7" name="Text 2">
+            <a:extLst>
+              <a:ext uri="{FF2B5EF4-FFF2-40B4-BE49-F238E27FC236}">
+                <a16:creationId xmlns:a16="http://schemas.microsoft.com/office/drawing/2014/main" id="{73192638-F831-5836-38B1-32A1616BE347}"/>
+              </a:ext>
+            </a:extLst>
+          </p:cNvPr>
+          <p:cNvSpPr/>
+          <p:nvPr/>
+        </p:nvSpPr>
+        <p:spPr>
+          <a:xfrm>
+            <a:off x="457200" y="54864"/>
+            <a:ext cx="3200400" cy="256032"/>
+          </a:xfrm>
+          <a:prstGeom prst="rect">
+            <a:avLst/>
+          </a:prstGeom>
+          <a:noFill/>
+          <a:ln/>
+        </p:spPr>
+        <p:txBody>
+          <a:bodyPr wrap="square" lIns="0" tIns="0" rIns="0" bIns="0" rtlCol="0" anchor="ctr"/>
+          <a:lstStyle/>
+          <a:p>
+            <a:pPr marL="0" indent="0">
+              <a:buNone/>
+            </a:pPr>
+            <a:r>
+              <a:rPr lang="en-US" sz="900" b="1" kern="0" spc="300" dirty="0">
+                <a:solidFill>
+                  <a:srgbClr val="14B8A6"/>
+                </a:solidFill>
+              </a:rPr>
+              <a:t>FEATURE VALIDATION</a:t>
+            </a:r>
+            <a:endParaRPr lang="en-US" sz="900" dirty="0"/>
+          </a:p>
+        </p:txBody>
+      </p:sp>
     </p:spTree>
     <p:extLst>
       <p:ext uri="{BB962C8B-B14F-4D97-AF65-F5344CB8AC3E}">
@@ -19425,13 +19609,13 @@
   <p:clrMapOvr>
     <a:masterClrMapping/>
   </p:clrMapOvr>
-  <mc:AlternateContent xmlns:mc="http://schemas.openxmlformats.org/markup-compatibility/2006">
-    <mc:Choice xmlns:p159="http://schemas.microsoft.com/office/powerpoint/2015/09/main" Requires="p159">
+  <mc:AlternateContent xmlns:mc="http://schemas.openxmlformats.org/markup-compatibility/2006" xmlns:p159="http://schemas.microsoft.com/office/powerpoint/2015/09/main">
+    <mc:Choice Requires="p159">
       <p:transition xmlns:p14="http://schemas.microsoft.com/office/powerpoint/2010/main" spd="slow" p14:dur="2000">
         <p159:morph option="byObject"/>
       </p:transition>
     </mc:Choice>
-    <mc:Fallback>
+    <mc:Fallback xmlns="">
       <p:transition spd="slow">
         <p:fade/>
       </p:transition>

</xml_diff>